<commit_message>
feat(templates): diversify role-aware image references
Add original calibration imagery and deterministic role-specific selection so image-led templates do not repeat one photograph across every page. Keep styles that prohibit photography on native visual carriers.
</commit_message>
<xml_diff>
--- a/skills/presentation-template-library/skills/artifact-template-amber-committee-memo/assets/reference.pptx
+++ b/skills/presentation-template-library/skills/artifact-template-amber-committee-memo/assets/reference.pptx
@@ -6019,7 +6019,7 @@
         </p:xfrm>
         <a:graphic xmlns:a="http://schemas.openxmlformats.org/drawingml/2006/main">
           <a:graphicData uri="http://schemas.openxmlformats.org/drawingml/2006/chart">
-            <c:chart xmlns:r="http://schemas.openxmlformats.org/officeDocument/2006/relationships" xmlns:c="http://schemas.openxmlformats.org/drawingml/2006/chart" r:id="R5f71a51578774aa9"/>
+            <c:chart xmlns:r="http://schemas.openxmlformats.org/officeDocument/2006/relationships" xmlns:c="http://schemas.openxmlformats.org/drawingml/2006/chart" r:id="Ra94510e5e5194630"/>
           </a:graphicData>
         </a:graphic>
       </p:graphicFrame>
@@ -6037,7 +6037,7 @@
         </p:xfrm>
         <a:graphic xmlns:a="http://schemas.openxmlformats.org/drawingml/2006/main">
           <a:graphicData uri="http://schemas.openxmlformats.org/drawingml/2006/chart">
-            <c:chart xmlns:r="http://schemas.openxmlformats.org/officeDocument/2006/relationships" xmlns:c="http://schemas.openxmlformats.org/drawingml/2006/chart" r:id="Rf0283ac34d584357"/>
+            <c:chart xmlns:r="http://schemas.openxmlformats.org/officeDocument/2006/relationships" xmlns:c="http://schemas.openxmlformats.org/drawingml/2006/chart" r:id="Rd1f204e98acf4739"/>
           </a:graphicData>
         </a:graphic>
       </p:graphicFrame>

</xml_diff>

<commit_message>
feat(templates): expand clean-room image calibration pools
</commit_message>
<xml_diff>
--- a/skills/presentation-template-library/skills/artifact-template-amber-committee-memo/assets/reference.pptx
+++ b/skills/presentation-template-library/skills/artifact-template-amber-committee-memo/assets/reference.pptx
@@ -6019,7 +6019,7 @@
         </p:xfrm>
         <a:graphic xmlns:a="http://schemas.openxmlformats.org/drawingml/2006/main">
           <a:graphicData uri="http://schemas.openxmlformats.org/drawingml/2006/chart">
-            <c:chart xmlns:r="http://schemas.openxmlformats.org/officeDocument/2006/relationships" xmlns:c="http://schemas.openxmlformats.org/drawingml/2006/chart" r:id="Ra94510e5e5194630"/>
+            <c:chart xmlns:r="http://schemas.openxmlformats.org/officeDocument/2006/relationships" xmlns:c="http://schemas.openxmlformats.org/drawingml/2006/chart" r:id="Rb2b7fe4e377141ca"/>
           </a:graphicData>
         </a:graphic>
       </p:graphicFrame>
@@ -6037,7 +6037,7 @@
         </p:xfrm>
         <a:graphic xmlns:a="http://schemas.openxmlformats.org/drawingml/2006/main">
           <a:graphicData uri="http://schemas.openxmlformats.org/drawingml/2006/chart">
-            <c:chart xmlns:r="http://schemas.openxmlformats.org/officeDocument/2006/relationships" xmlns:c="http://schemas.openxmlformats.org/drawingml/2006/chart" r:id="Rd1f204e98acf4739"/>
+            <c:chart xmlns:r="http://schemas.openxmlformats.org/officeDocument/2006/relationships" xmlns:c="http://schemas.openxmlformats.org/drawingml/2006/chart" r:id="Rebe7ba36982c4275"/>
           </a:graphicData>
         </a:graphic>
       </p:graphicFrame>

</xml_diff>

<commit_message>
docs(templates): refresh native background evidence
</commit_message>
<xml_diff>
--- a/skills/presentation-template-library/skills/artifact-template-amber-committee-memo/assets/reference.pptx
+++ b/skills/presentation-template-library/skills/artifact-template-amber-committee-memo/assets/reference.pptx
@@ -418,6 +418,16 @@
 <file path=ppt/slides/slide1.xml><?xml version="1.0" encoding="utf-8"?>
 <p:sld xmlns:p="http://schemas.openxmlformats.org/presentationml/2006/main">
   <p:cSld name="Opening claim">
+    <p:bg>
+      <p:bgPr>
+        <a:blipFill xmlns:a="http://schemas.openxmlformats.org/drawingml/2006/main">
+          <a:blip xmlns:r="http://schemas.openxmlformats.org/officeDocument/2006/relationships" r:embed="rIdOfficeKitImage619a419f636bb1c3_1"/>
+          <a:stretch>
+            <a:fillRect/>
+          </a:stretch>
+        </a:blipFill>
+      </p:bgPr>
+    </p:bg>
     <p:spTree>
       <p:nvGrpSpPr>
         <p:cNvPr id="1" name=""/>
@@ -432,38 +442,9 @@
           <a:chExt cx="0" cy="0"/>
         </a:xfrm>
       </p:grpSpPr>
-      <p:pic>
-        <p:nvPicPr>
-          <p:cNvPr id="2" name="artifact-template-amber-committee-memo-cover-field">
-            <a:extLst xmlns:a="http://schemas.openxmlformats.org/drawingml/2006/main">
-              <a:ext uri="{C183D7F6-B498-43B3-948B-1728B52AA6E4}">
-                <adec:decorative xmlns:adec="http://schemas.microsoft.com/office/drawing/2017/decorative" val="1"/>
-              </a:ext>
-            </a:extLst>
-          </p:cNvPr>
-          <p:cNvPicPr/>
-          <p:nvPr/>
-        </p:nvPicPr>
-        <p:blipFill>
-          <a:blip xmlns:r="http://schemas.openxmlformats.org/officeDocument/2006/relationships" xmlns:a="http://schemas.openxmlformats.org/drawingml/2006/main" r:embed="rIdOfficeKitImage619a419f636bb1c3_1"/>
-          <a:srcRect xmlns:a="http://schemas.openxmlformats.org/drawingml/2006/main" l="0" t="34180" r="0" b="34180"/>
-          <a:stretch xmlns:a="http://schemas.openxmlformats.org/drawingml/2006/main">
-            <a:fillRect/>
-          </a:stretch>
-        </p:blipFill>
-        <p:spPr>
-          <a:xfrm xmlns:a="http://schemas.openxmlformats.org/drawingml/2006/main">
-            <a:off x="0" y="0"/>
-            <a:ext cx="15240000" cy="8572500"/>
-          </a:xfrm>
-          <a:prstGeom xmlns:a="http://schemas.openxmlformats.org/drawingml/2006/main" prst="rect">
-            <a:avLst/>
-          </a:prstGeom>
-        </p:spPr>
-      </p:pic>
-      <p:sp>
-        <p:nvSpPr>
-          <p:cNvPr id="3" name="cover-paper-scrim"/>
+      <p:sp>
+        <p:nvSpPr>
+          <p:cNvPr id="2" name="cover-paper-scrim"/>
           <p:cNvSpPr/>
           <p:nvPr/>
         </p:nvSpPr>
@@ -501,7 +482,7 @@
       </p:sp>
       <p:sp>
         <p:nvSpPr>
-          <p:cNvPr id="4" name="fixed-rail"/>
+          <p:cNvPr id="3" name="fixed-rail"/>
           <p:cNvSpPr/>
           <p:nvPr/>
         </p:nvSpPr>
@@ -537,7 +518,7 @@
       </p:sp>
       <p:sp>
         <p:nvSpPr>
-          <p:cNvPr id="5" name="fixed-nav-0"/>
+          <p:cNvPr id="4" name="fixed-nav-0"/>
           <p:cNvSpPr/>
           <p:nvPr/>
         </p:nvSpPr>
@@ -573,7 +554,7 @@
       </p:sp>
       <p:sp>
         <p:nvSpPr>
-          <p:cNvPr id="6" name="fixed-nav-label-0"/>
+          <p:cNvPr id="5" name="fixed-nav-label-0"/>
           <p:cNvSpPr txBox="1"/>
           <p:nvPr/>
         </p:nvSpPr>
@@ -611,7 +592,7 @@
       </p:sp>
       <p:sp>
         <p:nvSpPr>
-          <p:cNvPr id="7" name="fixed-nav-1"/>
+          <p:cNvPr id="6" name="fixed-nav-1"/>
           <p:cNvSpPr/>
           <p:nvPr/>
         </p:nvSpPr>
@@ -647,7 +628,7 @@
       </p:sp>
       <p:sp>
         <p:nvSpPr>
-          <p:cNvPr id="8" name="fixed-nav-label-1"/>
+          <p:cNvPr id="7" name="fixed-nav-label-1"/>
           <p:cNvSpPr txBox="1"/>
           <p:nvPr/>
         </p:nvSpPr>
@@ -685,7 +666,7 @@
       </p:sp>
       <p:sp>
         <p:nvSpPr>
-          <p:cNvPr id="9" name="fixed-nav-2"/>
+          <p:cNvPr id="8" name="fixed-nav-2"/>
           <p:cNvSpPr/>
           <p:nvPr/>
         </p:nvSpPr>
@@ -721,7 +702,7 @@
       </p:sp>
       <p:sp>
         <p:nvSpPr>
-          <p:cNvPr id="10" name="fixed-nav-label-2"/>
+          <p:cNvPr id="9" name="fixed-nav-label-2"/>
           <p:cNvSpPr txBox="1"/>
           <p:nvPr/>
         </p:nvSpPr>
@@ -759,7 +740,7 @@
       </p:sp>
       <p:sp>
         <p:nvSpPr>
-          <p:cNvPr id="11" name="fixed-nav-3"/>
+          <p:cNvPr id="10" name="fixed-nav-3"/>
           <p:cNvSpPr/>
           <p:nvPr/>
         </p:nvSpPr>
@@ -795,7 +776,7 @@
       </p:sp>
       <p:sp>
         <p:nvSpPr>
-          <p:cNvPr id="12" name="fixed-nav-label-3"/>
+          <p:cNvPr id="11" name="fixed-nav-label-3"/>
           <p:cNvSpPr txBox="1"/>
           <p:nvPr/>
         </p:nvSpPr>
@@ -833,7 +814,7 @@
       </p:sp>
       <p:sp>
         <p:nvSpPr>
-          <p:cNvPr id="13" name="fixed-nav-4"/>
+          <p:cNvPr id="12" name="fixed-nav-4"/>
           <p:cNvSpPr/>
           <p:nvPr/>
         </p:nvSpPr>
@@ -869,7 +850,7 @@
       </p:sp>
       <p:sp>
         <p:nvSpPr>
-          <p:cNvPr id="14" name="fixed-nav-label-4"/>
+          <p:cNvPr id="13" name="fixed-nav-label-4"/>
           <p:cNvSpPr txBox="1"/>
           <p:nvPr/>
         </p:nvSpPr>
@@ -907,7 +888,7 @@
       </p:sp>
       <p:sp>
         <p:nvSpPr>
-          <p:cNvPr id="15" name="top-rule"/>
+          <p:cNvPr id="14" name="top-rule"/>
           <p:cNvSpPr/>
           <p:nvPr/>
         </p:nvSpPr>
@@ -941,7 +922,7 @@
       </p:sp>
       <p:sp>
         <p:nvSpPr>
-          <p:cNvPr id="16" name="eyebrow"/>
+          <p:cNvPr id="15" name="eyebrow"/>
           <p:cNvSpPr txBox="1"/>
           <p:nvPr/>
         </p:nvSpPr>
@@ -978,7 +959,7 @@
       </p:sp>
       <p:sp>
         <p:nvSpPr>
-          <p:cNvPr id="17" name="cover-title"/>
+          <p:cNvPr id="16" name="cover-title"/>
           <p:cNvSpPr txBox="1"/>
           <p:nvPr/>
         </p:nvSpPr>
@@ -1015,7 +996,7 @@
       </p:sp>
       <p:sp>
         <p:nvSpPr>
-          <p:cNvPr id="18" name="cover-subtitle"/>
+          <p:cNvPr id="17" name="cover-subtitle"/>
           <p:cNvSpPr txBox="1"/>
           <p:nvPr/>
         </p:nvSpPr>
@@ -1052,7 +1033,7 @@
       </p:sp>
       <p:sp>
         <p:nvSpPr>
-          <p:cNvPr id="19" name="cover-rule"/>
+          <p:cNvPr id="18" name="cover-rule"/>
           <p:cNvSpPr/>
           <p:nvPr/>
         </p:nvSpPr>
@@ -1086,7 +1067,7 @@
       </p:sp>
       <p:sp>
         <p:nvSpPr>
-          <p:cNvPr id="20" name="cover-basis"/>
+          <p:cNvPr id="19" name="cover-basis"/>
           <p:cNvSpPr txBox="1"/>
           <p:nvPr/>
         </p:nvSpPr>
@@ -1123,7 +1104,7 @@
       </p:sp>
       <p:sp>
         <p:nvSpPr>
-          <p:cNvPr id="21" name="cover-thesis"/>
+          <p:cNvPr id="20" name="cover-thesis"/>
           <p:cNvSpPr txBox="1"/>
           <p:nvPr/>
         </p:nvSpPr>
@@ -1160,7 +1141,7 @@
       </p:sp>
       <p:sp>
         <p:nvSpPr>
-          <p:cNvPr id="22" name="cover-source"/>
+          <p:cNvPr id="21" name="cover-source"/>
           <p:cNvSpPr txBox="1"/>
           <p:nvPr/>
         </p:nvSpPr>
@@ -1197,7 +1178,7 @@
       </p:sp>
       <p:sp>
         <p:nvSpPr>
-          <p:cNvPr id="23" name="page-number"/>
+          <p:cNvPr id="22" name="page-number"/>
           <p:cNvSpPr txBox="1"/>
           <p:nvPr/>
         </p:nvSpPr>
@@ -1235,7 +1216,7 @@
       </p:sp>
       <p:sp>
         <p:nvSpPr>
-          <p:cNvPr id="24" name="anchor-field"/>
+          <p:cNvPr id="23" name="anchor-field"/>
           <p:cNvSpPr/>
           <p:nvPr/>
         </p:nvSpPr>
@@ -1271,7 +1252,7 @@
       </p:sp>
       <p:sp>
         <p:nvSpPr>
-          <p:cNvPr id="25" name="anchor-line"/>
+          <p:cNvPr id="24" name="anchor-line"/>
           <p:cNvSpPr/>
           <p:nvPr/>
         </p:nvSpPr>
@@ -1305,7 +1286,7 @@
       </p:sp>
       <p:sp>
         <p:nvSpPr>
-          <p:cNvPr id="26" name="anchor-line-two"/>
+          <p:cNvPr id="25" name="anchor-line-two"/>
           <p:cNvSpPr/>
           <p:nvPr/>
         </p:nvSpPr>
@@ -1339,7 +1320,7 @@
       </p:sp>
       <p:sp>
         <p:nvSpPr>
-          <p:cNvPr id="27" name="anchor-dot"/>
+          <p:cNvPr id="26" name="anchor-dot"/>
           <p:cNvSpPr/>
           <p:nvPr/>
         </p:nvSpPr>
@@ -6019,7 +6000,7 @@
         </p:xfrm>
         <a:graphic xmlns:a="http://schemas.openxmlformats.org/drawingml/2006/main">
           <a:graphicData uri="http://schemas.openxmlformats.org/drawingml/2006/chart">
-            <c:chart xmlns:r="http://schemas.openxmlformats.org/officeDocument/2006/relationships" xmlns:c="http://schemas.openxmlformats.org/drawingml/2006/chart" r:id="Rb2b7fe4e377141ca"/>
+            <c:chart xmlns:r="http://schemas.openxmlformats.org/officeDocument/2006/relationships" xmlns:c="http://schemas.openxmlformats.org/drawingml/2006/chart" r:id="R56cede0e971d47a2"/>
           </a:graphicData>
         </a:graphic>
       </p:graphicFrame>
@@ -6037,7 +6018,7 @@
         </p:xfrm>
         <a:graphic xmlns:a="http://schemas.openxmlformats.org/drawingml/2006/main">
           <a:graphicData uri="http://schemas.openxmlformats.org/drawingml/2006/chart">
-            <c:chart xmlns:r="http://schemas.openxmlformats.org/officeDocument/2006/relationships" xmlns:c="http://schemas.openxmlformats.org/drawingml/2006/chart" r:id="Rebe7ba36982c4275"/>
+            <c:chart xmlns:r="http://schemas.openxmlformats.org/officeDocument/2006/relationships" xmlns:c="http://schemas.openxmlformats.org/drawingml/2006/chart" r:id="R194bee7178354b8d"/>
           </a:graphicData>
         </a:graphic>
       </p:graphicFrame>

</xml_diff>

<commit_message>
feat(templates): diversify image-led reference assets
</commit_message>
<xml_diff>
--- a/skills/presentation-template-library/skills/artifact-template-amber-committee-memo/assets/reference.pptx
+++ b/skills/presentation-template-library/skills/artifact-template-amber-committee-memo/assets/reference.pptx
@@ -6000,7 +6000,7 @@
         </p:xfrm>
         <a:graphic xmlns:a="http://schemas.openxmlformats.org/drawingml/2006/main">
           <a:graphicData uri="http://schemas.openxmlformats.org/drawingml/2006/chart">
-            <c:chart xmlns:r="http://schemas.openxmlformats.org/officeDocument/2006/relationships" xmlns:c="http://schemas.openxmlformats.org/drawingml/2006/chart" r:id="Refd3260e60ec4ae9"/>
+            <c:chart xmlns:r="http://schemas.openxmlformats.org/officeDocument/2006/relationships" xmlns:c="http://schemas.openxmlformats.org/drawingml/2006/chart" r:id="R0024a3e46a96487c"/>
           </a:graphicData>
         </a:graphic>
       </p:graphicFrame>
@@ -6018,7 +6018,7 @@
         </p:xfrm>
         <a:graphic xmlns:a="http://schemas.openxmlformats.org/drawingml/2006/main">
           <a:graphicData uri="http://schemas.openxmlformats.org/drawingml/2006/chart">
-            <c:chart xmlns:r="http://schemas.openxmlformats.org/officeDocument/2006/relationships" xmlns:c="http://schemas.openxmlformats.org/drawingml/2006/chart" r:id="R79377da46ee2499f"/>
+            <c:chart xmlns:r="http://schemas.openxmlformats.org/officeDocument/2006/relationships" xmlns:c="http://schemas.openxmlformats.org/drawingml/2006/chart" r:id="Ra530623eb5d746cc"/>
           </a:graphicData>
         </a:graphic>
       </p:graphicFrame>

</xml_diff>

<commit_message>
feat(templates): expand clean-room image roles
</commit_message>
<xml_diff>
--- a/skills/presentation-template-library/skills/artifact-template-amber-committee-memo/assets/reference.pptx
+++ b/skills/presentation-template-library/skills/artifact-template-amber-committee-memo/assets/reference.pptx
@@ -6000,7 +6000,7 @@
         </p:xfrm>
         <a:graphic xmlns:a="http://schemas.openxmlformats.org/drawingml/2006/main">
           <a:graphicData uri="http://schemas.openxmlformats.org/drawingml/2006/chart">
-            <c:chart xmlns:r="http://schemas.openxmlformats.org/officeDocument/2006/relationships" xmlns:c="http://schemas.openxmlformats.org/drawingml/2006/chart" r:id="R0024a3e46a96487c"/>
+            <c:chart xmlns:r="http://schemas.openxmlformats.org/officeDocument/2006/relationships" xmlns:c="http://schemas.openxmlformats.org/drawingml/2006/chart" r:id="Rb05f371a7ec64e73"/>
           </a:graphicData>
         </a:graphic>
       </p:graphicFrame>
@@ -6018,7 +6018,7 @@
         </p:xfrm>
         <a:graphic xmlns:a="http://schemas.openxmlformats.org/drawingml/2006/main">
           <a:graphicData uri="http://schemas.openxmlformats.org/drawingml/2006/chart">
-            <c:chart xmlns:r="http://schemas.openxmlformats.org/officeDocument/2006/relationships" xmlns:c="http://schemas.openxmlformats.org/drawingml/2006/chart" r:id="Ra530623eb5d746cc"/>
+            <c:chart xmlns:r="http://schemas.openxmlformats.org/officeDocument/2006/relationships" xmlns:c="http://schemas.openxmlformats.org/drawingml/2006/chart" r:id="R7da46f2b49fe4e16"/>
           </a:graphicData>
         </a:graphic>
       </p:graphicFrame>

</xml_diff>

<commit_message>
feat(templates): route clean-room references by source traits
</commit_message>
<xml_diff>
--- a/skills/presentation-template-library/skills/artifact-template-amber-committee-memo/assets/reference.pptx
+++ b/skills/presentation-template-library/skills/artifact-template-amber-committee-memo/assets/reference.pptx
@@ -421,7 +421,7 @@
     <p:bg>
       <p:bgPr>
         <a:blipFill xmlns:a="http://schemas.openxmlformats.org/drawingml/2006/main">
-          <a:blip xmlns:r="http://schemas.openxmlformats.org/officeDocument/2006/relationships" r:embed="rIdOfficeKitImage619a419f636bb1c3_1"/>
+          <a:blip xmlns:r="http://schemas.openxmlformats.org/officeDocument/2006/relationships" r:embed="rIdOfficeKitImage2a41c7724b7be4dd_1"/>
           <a:stretch>
             <a:fillRect/>
           </a:stretch>
@@ -6000,7 +6000,7 @@
         </p:xfrm>
         <a:graphic xmlns:a="http://schemas.openxmlformats.org/drawingml/2006/main">
           <a:graphicData uri="http://schemas.openxmlformats.org/drawingml/2006/chart">
-            <c:chart xmlns:r="http://schemas.openxmlformats.org/officeDocument/2006/relationships" xmlns:c="http://schemas.openxmlformats.org/drawingml/2006/chart" r:id="Rb05f371a7ec64e73"/>
+            <c:chart xmlns:r="http://schemas.openxmlformats.org/officeDocument/2006/relationships" xmlns:c="http://schemas.openxmlformats.org/drawingml/2006/chart" r:id="Ra1171804bbd54c89"/>
           </a:graphicData>
         </a:graphic>
       </p:graphicFrame>
@@ -6018,7 +6018,7 @@
         </p:xfrm>
         <a:graphic xmlns:a="http://schemas.openxmlformats.org/drawingml/2006/main">
           <a:graphicData uri="http://schemas.openxmlformats.org/drawingml/2006/chart">
-            <c:chart xmlns:r="http://schemas.openxmlformats.org/officeDocument/2006/relationships" xmlns:c="http://schemas.openxmlformats.org/drawingml/2006/chart" r:id="R7da46f2b49fe4e16"/>
+            <c:chart xmlns:r="http://schemas.openxmlformats.org/officeDocument/2006/relationships" xmlns:c="http://schemas.openxmlformats.org/drawingml/2006/chart" r:id="R7b4dc88eccea4e7f"/>
           </a:graphicData>
         </a:graphic>
       </p:graphicFrame>

</xml_diff>